<commit_message>
site+deck: v0.2.0 content — zero-selector onboarding, attribute anchoring, data out, autopilot
Co-Authored-By: Claude Fable 5 <noreply@anthropic.com>
</commit_message>
<xml_diff>
--- a/docs/reweave-deck.pptx
+++ b/docs/reweave-deck.pptx
@@ -511,7 +511,7 @@
           <a:p>
             <a:r>
               <a:rPr lang="en-US" dirty="0"/>
-              <a:t>Reweave: self-healing web data pipelines. The one-line pitch: when a website redesign silently breaks your scraper, an agent detects it, repairs it, proves the repair against ground truth, and a named human approves the deploy.</a:t>
+              <a:t>Reweave v0.2.0: self-healing web data pipelines. The pitch: when a website redesign silently breaks your scraper, an agent detects it, repairs it, proves the repair against ground truth, and a named human approves the deploy. New in v0.2.0: you never write a selector at all — sources onboard from a URL plus a few pasted golden examples.</a:t>
             </a:r>
             <a:endParaRPr lang="en-US" dirty="0"/>
           </a:p>
@@ -599,7 +599,7 @@
           <a:p>
             <a:r>
               <a:rPr lang="en-US" dirty="0"/>
-              <a:t>Roadmap: multi-fleet SaaS, auto-tiered autonomy where repairs earn trust, and drift prediction. The ask: try it, break it, watch it heal — repo and live demo are both public.</a:t>
+              <a:t>Roadmap: multi-fleet SaaS, auto-tiered autonomy building on the v0.2.0 autopilot (repairs earn trust until high-confidence heals auto-deploy), and drift prediction. The ask: try it, break it, watch it heal — repo and live demo are both public.</a:t>
             </a:r>
             <a:endParaRPr lang="en-US" dirty="0"/>
           </a:p>
@@ -863,7 +863,7 @@
           <a:p>
             <a:r>
               <a:rPr lang="en-US" dirty="0"/>
-              <a:t>The 30-second story: Sentinel detects silent drift via golden-record validation, Surgeon synthesizes a repaired spec, every candidate is validated against ground truth, a named human approves at the Gate, and the immutable new spec deploys.</a:t>
+              <a:t>The 30-second story: Sentinel detects silent drift via golden-record validation, Surgeon synthesizes a repaired spec, every candidate is validated against ground truth, a named human approves at the Gate, and the immutable new spec deploys. New in v0.2.0: the same machinery handles day zero — paste a URL and a few golden examples and the Surgeon synthesizes AND validates the initial spec. Live proof: books.toscrape.com onboarded from 3 pasted examples to 20 rows at 100% confidence. You never write a selector.</a:t>
             </a:r>
             <a:endParaRPr lang="en-US" dirty="0"/>
           </a:p>
@@ -1039,7 +1039,7 @@
           <a:p>
             <a:r>
               <a:rPr lang="en-US" dirty="0"/>
-              <a:t>The algorithm: anchor known-true facts in the new DOM, ascend to item containers, generalize shared CSS signatures, and validate every candidate against ALL golden records. LLM suggestions get no shortcut — they pass the same validation.</a:t>
+              <a:t>The algorithm: anchor known-true facts in the new DOM — in node text or in attributes like title= and alt=, since real catalogs truncate visible titles — ascend to item containers, generalize per-shape candidate groups picking the most-specific container, and validate every candidate against ALL golden records. LLM suggestions get no shortcut — they pass the same validation. In v0.2.0 this exact machinery also bootstraps brand-new sources from pasted examples: 3 examples generalized to a 20-item page.</a:t>
             </a:r>
             <a:endParaRPr lang="en-US" dirty="0"/>
           </a:p>
@@ -1127,7 +1127,7 @@
           <a:p>
             <a:r>
               <a:rPr lang="en-US" dirty="0"/>
-              <a:t>Safety is layered: Reweave's own approval gate, the MCP destructiveHint contract, and TrueForge's harness-level approval policy. Underneath: immutable spec versions, named-actor audit logs, and a deterministic extractor.</a:t>
+              <a:t>Safety is layered: Reweave's own approval gate, the MCP destructiveHint contract, and TrueForge's harness-level approval policy. Underneath: immutable spec versions, named-actor audit logs, and a deterministic extractor. New in v0.2.0: autopilot monitors every source continuously (60-second default, dashboard toggle) — but autonomy stops at the gate: deploys still require a named human.</a:t>
             </a:r>
             <a:endParaRPr lang="en-US" dirty="0"/>
           </a:p>
@@ -1215,7 +1215,7 @@
           <a:p>
             <a:r>
               <a:rPr lang="en-US" dirty="0"/>
-              <a:t>Every sponsor is load-bearing: TrueForge drives Reweave over MCP with a SKILL.md operator pack, Bright Data's Web Unlocker is the fetch layer, and Qodo's quality bar shows in the 13-test pytest suite including full lifecycle E2E.</a:t>
+              <a:t>Every sponsor is load-bearing: TrueForge drives Reweave over MCP — now 9 tools including add_source and get_rows — with a SKILL.md operator pack, Bright Data's Web Unlocker is the fetch layer, and Qodo's quality bar shows in the 20-test pytest suite including full lifecycle E2E.</a:t>
             </a:r>
             <a:endParaRPr lang="en-US" dirty="0"/>
           </a:p>
@@ -1303,7 +1303,7 @@
           <a:p>
             <a:r>
               <a:rPr lang="en-US" dirty="0"/>
-              <a:t>The impact is on screen, not in a spreadsheet: the dashboard books every heal to a live ledger. At fleet scale the math is $46,312 a year of recovered toil for a 50-scraper fleet — using conservative per-heal numbers.</a:t>
+              <a:t>The impact is on screen, not in a spreadsheet: the dashboard books every heal to a live ledger. At fleet scale the math is $46,312 a year of recovered toil for a 50-scraper fleet — using conservative per-heal numbers. And in v0.2.0 the data actually flows out: runs are stored per source, a data drawer on the dashboard, CSV/JSON export, and an MCP get_rows tool — while autopilot re-checks every source on a 60-second cadence with deploys still human-gated.</a:t>
             </a:r>
             <a:endParaRPr lang="en-US" dirty="0"/>
           </a:p>
@@ -1837,16 +1837,16 @@
         <p:spPr>
           <a:xfrm>
             <a:off x="822960" y="4617720"/>
-            <a:ext cx="5212080" cy="685800"/>
-          </a:xfrm>
-          <a:prstGeom prst="rect">
-            <a:avLst/>
-          </a:prstGeom>
-          <a:noFill/>
-          <a:ln/>
-        </p:spPr>
-        <p:txBody>
-          <a:bodyPr wrap="square" lIns="0" tIns="0" rIns="0" bIns="0" rtlCol="0" anchor="ctr"/>
+            <a:ext cx="5212080" cy="868680"/>
+          </a:xfrm>
+          <a:prstGeom prst="rect">
+            <a:avLst/>
+          </a:prstGeom>
+          <a:noFill/>
+          <a:ln/>
+        </p:spPr>
+        <p:txBody>
+          <a:bodyPr wrap="square" lIns="0" tIns="0" rIns="0" bIns="0" rtlCol="0" anchor="t"/>
           <a:lstStyle/>
           <a:p>
             <a:pPr indent="0" marL="0">
@@ -1864,7 +1864,7 @@
                 <a:ea typeface="Arial" pitchFamily="34" charset="-122"/>
                 <a:cs typeface="Arial" pitchFamily="34" charset="-120"/>
               </a:rPr>
-              <a:t>An autonomous repair agent for web scrapers — with a human holding the deploy key.</a:t>
+              <a:t>An autonomous repair agent for web scrapers — you never write a selector, and a human holds the deploy key.</a:t>
             </a:r>
             <a:endParaRPr lang="en-US" sz="1400" dirty="0"/>
           </a:p>
@@ -1965,8 +1965,8 @@
         </p:nvSpPr>
         <p:spPr>
           <a:xfrm>
-            <a:off x="6949440" y="1874520"/>
-            <a:ext cx="4434840" cy="2560320"/>
+            <a:off x="6949440" y="1828800"/>
+            <a:ext cx="4434840" cy="2606040"/>
           </a:xfrm>
           <a:prstGeom prst="rect">
             <a:avLst/>
@@ -1980,7 +1980,7 @@
           <a:p>
             <a:pPr algn="l" indent="0" marL="0">
               <a:lnSpc>
-                <a:spcPct val="165000"/>
+                <a:spcPct val="150000"/>
               </a:lnSpc>
               <a:buNone/>
             </a:pPr>
@@ -1993,114 +1993,154 @@
                 <a:ea typeface="Courier New" pitchFamily="34" charset="-122"/>
                 <a:cs typeface="Courier New" pitchFamily="34" charset="-120"/>
               </a:rPr>
-              <a:t>$ reweave run demo://nimbusmart</a:t>
+              <a:t>$ reweave add books.toscrape.com +3 examples</a:t>
             </a:r>
             <a:endParaRPr lang="en-US" sz="1050" dirty="0"/>
           </a:p>
           <a:p>
             <a:pPr algn="l" indent="0" marL="0">
               <a:lnSpc>
-                <a:spcPct val="165000"/>
+                <a:spcPct val="150000"/>
               </a:lnSpc>
               <a:buNone/>
             </a:pPr>
             <a:r>
               <a:rPr lang="en-US" sz="1050" dirty="0">
                 <a:solidFill>
-                  <a:srgbClr val="FF7B72"/>
-                </a:solidFill>
-                <a:latin typeface="Courier New" pitchFamily="34" charset="0"/>
-                <a:ea typeface="Courier New" pitchFamily="34" charset="-122"/>
-                <a:cs typeface="Courier New" pitchFamily="34" charset="-120"/>
-              </a:rPr>
-              <a:t>• target site shipped a redesign</a:t>
+                  <a:srgbClr val="3DDC84"/>
+                </a:solidFill>
+                <a:latin typeface="Courier New" pitchFamily="34" charset="0"/>
+                <a:ea typeface="Courier New" pitchFamily="34" charset="-122"/>
+                <a:cs typeface="Courier New" pitchFamily="34" charset="-120"/>
+              </a:rPr>
+              <a:t>• spec v1 synthesized — no selectors written</a:t>
             </a:r>
             <a:endParaRPr lang="en-US" sz="1050" dirty="0"/>
           </a:p>
           <a:p>
             <a:pPr algn="l" indent="0" marL="0">
               <a:lnSpc>
-                <a:spcPct val="165000"/>
+                <a:spcPct val="150000"/>
               </a:lnSpc>
               <a:buNone/>
             </a:pPr>
             <a:r>
               <a:rPr lang="en-US" sz="1050" dirty="0">
                 <a:solidFill>
-                  <a:srgbClr val="FFB454"/>
-                </a:solidFill>
-                <a:latin typeface="Courier New" pitchFamily="34" charset="0"/>
-                <a:ea typeface="Courier New" pitchFamily="34" charset="-122"/>
-                <a:cs typeface="Courier New" pitchFamily="34" charset="-120"/>
-              </a:rPr>
-              <a:t>• drift detected: 8 rows → 0 · 100% nulls</a:t>
+                  <a:srgbClr val="8B96A8"/>
+                </a:solidFill>
+                <a:latin typeface="Courier New" pitchFamily="34" charset="0"/>
+                <a:ea typeface="Courier New" pitchFamily="34" charset="-122"/>
+                <a:cs typeface="Courier New" pitchFamily="34" charset="-120"/>
+              </a:rPr>
+              <a:t>$ reweave run demo://nimbusmart</a:t>
             </a:r>
             <a:endParaRPr lang="en-US" sz="1050" dirty="0"/>
           </a:p>
           <a:p>
             <a:pPr algn="l" indent="0" marL="0">
               <a:lnSpc>
-                <a:spcPct val="165000"/>
+                <a:spcPct val="150000"/>
               </a:lnSpc>
               <a:buNone/>
             </a:pPr>
             <a:r>
               <a:rPr lang="en-US" sz="1050" dirty="0">
                 <a:solidFill>
-                  <a:srgbClr val="39D3E6"/>
-                </a:solidFill>
-                <a:latin typeface="Courier New" pitchFamily="34" charset="0"/>
-                <a:ea typeface="Courier New" pitchFamily="34" charset="-122"/>
-                <a:cs typeface="Courier New" pitchFamily="34" charset="-120"/>
-              </a:rPr>
-              <a:t>• surgeon: 4 selector changes synthesized</a:t>
+                  <a:srgbClr val="FF7B72"/>
+                </a:solidFill>
+                <a:latin typeface="Courier New" pitchFamily="34" charset="0"/>
+                <a:ea typeface="Courier New" pitchFamily="34" charset="-122"/>
+                <a:cs typeface="Courier New" pitchFamily="34" charset="-120"/>
+              </a:rPr>
+              <a:t>• target site shipped a redesign</a:t>
             </a:r>
             <a:endParaRPr lang="en-US" sz="1050" dirty="0"/>
           </a:p>
           <a:p>
             <a:pPr algn="l" indent="0" marL="0">
               <a:lnSpc>
-                <a:spcPct val="165000"/>
+                <a:spcPct val="150000"/>
               </a:lnSpc>
               <a:buNone/>
             </a:pPr>
             <a:r>
               <a:rPr lang="en-US" sz="1050" dirty="0">
                 <a:solidFill>
-                  <a:srgbClr val="39D3E6"/>
-                </a:solidFill>
-                <a:latin typeface="Courier New" pitchFamily="34" charset="0"/>
-                <a:ea typeface="Courier New" pitchFamily="34" charset="-122"/>
-                <a:cs typeface="Courier New" pitchFamily="34" charset="-120"/>
-              </a:rPr>
-              <a:t>• validated against 8/8 golden records</a:t>
+                  <a:srgbClr val="FFB454"/>
+                </a:solidFill>
+                <a:latin typeface="Courier New" pitchFamily="34" charset="0"/>
+                <a:ea typeface="Courier New" pitchFamily="34" charset="-122"/>
+                <a:cs typeface="Courier New" pitchFamily="34" charset="-120"/>
+              </a:rPr>
+              <a:t>• drift detected: 8 rows → 0 · 100% nulls</a:t>
             </a:r>
             <a:endParaRPr lang="en-US" sz="1050" dirty="0"/>
           </a:p>
           <a:p>
             <a:pPr algn="l" indent="0" marL="0">
               <a:lnSpc>
-                <a:spcPct val="165000"/>
+                <a:spcPct val="150000"/>
               </a:lnSpc>
               <a:buNone/>
             </a:pPr>
             <a:r>
               <a:rPr lang="en-US" sz="1050" dirty="0">
                 <a:solidFill>
-                  <a:srgbClr val="3DDC84"/>
-                </a:solidFill>
-                <a:latin typeface="Courier New" pitchFamily="34" charset="0"/>
-                <a:ea typeface="Courier New" pitchFamily="34" charset="-122"/>
-                <a:cs typeface="Courier New" pitchFamily="34" charset="-120"/>
-              </a:rPr>
-              <a:t>• heal approved by moorthy → spec v2 live</a:t>
+                  <a:srgbClr val="39D3E6"/>
+                </a:solidFill>
+                <a:latin typeface="Courier New" pitchFamily="34" charset="0"/>
+                <a:ea typeface="Courier New" pitchFamily="34" charset="-122"/>
+                <a:cs typeface="Courier New" pitchFamily="34" charset="-120"/>
+              </a:rPr>
+              <a:t>• surgeon: 4 selector changes synthesized</a:t>
             </a:r>
             <a:endParaRPr lang="en-US" sz="1050" dirty="0"/>
           </a:p>
           <a:p>
             <a:pPr algn="l" indent="0" marL="0">
               <a:lnSpc>
-                <a:spcPct val="165000"/>
+                <a:spcPct val="150000"/>
+              </a:lnSpc>
+              <a:buNone/>
+            </a:pPr>
+            <a:r>
+              <a:rPr lang="en-US" sz="1050" dirty="0">
+                <a:solidFill>
+                  <a:srgbClr val="39D3E6"/>
+                </a:solidFill>
+                <a:latin typeface="Courier New" pitchFamily="34" charset="0"/>
+                <a:ea typeface="Courier New" pitchFamily="34" charset="-122"/>
+                <a:cs typeface="Courier New" pitchFamily="34" charset="-120"/>
+              </a:rPr>
+              <a:t>• validated against 8/8 golden records</a:t>
+            </a:r>
+            <a:endParaRPr lang="en-US" sz="1050" dirty="0"/>
+          </a:p>
+          <a:p>
+            <a:pPr algn="l" indent="0" marL="0">
+              <a:lnSpc>
+                <a:spcPct val="150000"/>
+              </a:lnSpc>
+              <a:buNone/>
+            </a:pPr>
+            <a:r>
+              <a:rPr lang="en-US" sz="1050" dirty="0">
+                <a:solidFill>
+                  <a:srgbClr val="3DDC84"/>
+                </a:solidFill>
+                <a:latin typeface="Courier New" pitchFamily="34" charset="0"/>
+                <a:ea typeface="Courier New" pitchFamily="34" charset="-122"/>
+                <a:cs typeface="Courier New" pitchFamily="34" charset="-120"/>
+              </a:rPr>
+              <a:t>• heal approved by moorthy → spec v2 live</a:t>
+            </a:r>
+            <a:endParaRPr lang="en-US" sz="1050" dirty="0"/>
+          </a:p>
+          <a:p>
+            <a:pPr algn="l" indent="0" marL="0">
+              <a:lnSpc>
+                <a:spcPct val="150000"/>
               </a:lnSpc>
               <a:buNone/>
             </a:pPr>
@@ -2152,7 +2192,7 @@
                 <a:ea typeface="Courier New" pitchFamily="34" charset="-122"/>
                 <a:cs typeface="Courier New" pitchFamily="34" charset="-120"/>
               </a:rPr>
-              <a:t>Agent Harness Hackathon · Aug 30, 2026 · San Francisco · hosted at Bright Data · built on TrueForge</a:t>
+              <a:t>Agent Harness Hackathon · Aug 30, 2026 · San Francisco · hosted at Bright Data · built on TrueForge · v0.2.0</a:t>
             </a:r>
             <a:endParaRPr lang="en-US" sz="1100" dirty="0"/>
           </a:p>
@@ -2526,7 +2566,7 @@
                 <a:ea typeface="Arial" pitchFamily="34" charset="-122"/>
                 <a:cs typeface="Arial" pitchFamily="34" charset="-120"/>
               </a:rPr>
-              <a:t>Repairs earn trust: high-confidence heals auto-deploy, risky ones stay gated behind a human.</a:t>
+              <a:t>Autopilot already watches 24/7 — next, repairs earn trust: high-confidence heals auto-deploy, risky ones stay gated.</a:t>
             </a:r>
             <a:endParaRPr lang="en-US" sz="1150" dirty="0"/>
           </a:p>
@@ -4862,8 +4902,8 @@
         </p:nvSpPr>
         <p:spPr>
           <a:xfrm>
-            <a:off x="548640" y="1600200"/>
-            <a:ext cx="1965960" cy="2514600"/>
+            <a:off x="548640" y="1463040"/>
+            <a:ext cx="1965960" cy="2377440"/>
           </a:xfrm>
           <a:prstGeom prst="roundRect">
             <a:avLst>
@@ -4897,7 +4937,7 @@
         </p:blipFill>
         <p:spPr>
           <a:xfrm>
-            <a:off x="749808" y="1828800"/>
+            <a:off x="749808" y="1673352"/>
             <a:ext cx="347472" cy="347472"/>
           </a:xfrm>
           <a:prstGeom prst="rect">
@@ -4913,7 +4953,7 @@
         </p:nvSpPr>
         <p:spPr>
           <a:xfrm>
-            <a:off x="749808" y="2304288"/>
+            <a:off x="749808" y="2139696"/>
             <a:ext cx="1563624" cy="256032"/>
           </a:xfrm>
           <a:prstGeom prst="rect">
@@ -4952,7 +4992,7 @@
         </p:nvSpPr>
         <p:spPr>
           <a:xfrm>
-            <a:off x="749808" y="2560320"/>
+            <a:off x="749808" y="2395728"/>
             <a:ext cx="1563624" cy="292608"/>
           </a:xfrm>
           <a:prstGeom prst="rect">
@@ -4991,7 +5031,7 @@
         </p:nvSpPr>
         <p:spPr>
           <a:xfrm>
-            <a:off x="749808" y="2852928"/>
+            <a:off x="749808" y="2688336"/>
             <a:ext cx="1563624" cy="256032"/>
           </a:xfrm>
           <a:prstGeom prst="rect">
@@ -5030,8 +5070,8 @@
         </p:nvSpPr>
         <p:spPr>
           <a:xfrm>
-            <a:off x="749808" y="3154680"/>
-            <a:ext cx="1600200" cy="914400"/>
+            <a:off x="749808" y="2980944"/>
+            <a:ext cx="1600200" cy="777240"/>
           </a:xfrm>
           <a:prstGeom prst="rect">
             <a:avLst/>
@@ -5072,7 +5112,7 @@
         </p:nvSpPr>
         <p:spPr>
           <a:xfrm>
-            <a:off x="2496312" y="2606040"/>
+            <a:off x="2496312" y="2441448"/>
             <a:ext cx="352044" cy="365760"/>
           </a:xfrm>
           <a:prstGeom prst="rect">
@@ -5111,8 +5151,8 @@
         </p:nvSpPr>
         <p:spPr>
           <a:xfrm>
-            <a:off x="2830068" y="1600200"/>
-            <a:ext cx="1965960" cy="2514600"/>
+            <a:off x="2830068" y="1463040"/>
+            <a:ext cx="1965960" cy="2377440"/>
           </a:xfrm>
           <a:prstGeom prst="roundRect">
             <a:avLst>
@@ -5146,7 +5186,7 @@
         </p:blipFill>
         <p:spPr>
           <a:xfrm>
-            <a:off x="3031236" y="1828800"/>
+            <a:off x="3031236" y="1673352"/>
             <a:ext cx="347472" cy="347472"/>
           </a:xfrm>
           <a:prstGeom prst="rect">
@@ -5162,7 +5202,7 @@
         </p:nvSpPr>
         <p:spPr>
           <a:xfrm>
-            <a:off x="3031236" y="2304288"/>
+            <a:off x="3031236" y="2139696"/>
             <a:ext cx="1563624" cy="256032"/>
           </a:xfrm>
           <a:prstGeom prst="rect">
@@ -5201,7 +5241,7 @@
         </p:nvSpPr>
         <p:spPr>
           <a:xfrm>
-            <a:off x="3031236" y="2560320"/>
+            <a:off x="3031236" y="2395728"/>
             <a:ext cx="1563624" cy="292608"/>
           </a:xfrm>
           <a:prstGeom prst="rect">
@@ -5240,7 +5280,7 @@
         </p:nvSpPr>
         <p:spPr>
           <a:xfrm>
-            <a:off x="3031236" y="2852928"/>
+            <a:off x="3031236" y="2688336"/>
             <a:ext cx="1563624" cy="256032"/>
           </a:xfrm>
           <a:prstGeom prst="rect">
@@ -5279,8 +5319,8 @@
         </p:nvSpPr>
         <p:spPr>
           <a:xfrm>
-            <a:off x="3031236" y="3154680"/>
-            <a:ext cx="1600200" cy="914400"/>
+            <a:off x="3031236" y="2980944"/>
+            <a:ext cx="1600200" cy="777240"/>
           </a:xfrm>
           <a:prstGeom prst="rect">
             <a:avLst/>
@@ -5321,7 +5361,7 @@
         </p:nvSpPr>
         <p:spPr>
           <a:xfrm>
-            <a:off x="4777740" y="2606040"/>
+            <a:off x="4777740" y="2441448"/>
             <a:ext cx="352044" cy="365760"/>
           </a:xfrm>
           <a:prstGeom prst="rect">
@@ -5360,8 +5400,8 @@
         </p:nvSpPr>
         <p:spPr>
           <a:xfrm>
-            <a:off x="5111496" y="1600200"/>
-            <a:ext cx="1965960" cy="2514600"/>
+            <a:off x="5111496" y="1463040"/>
+            <a:ext cx="1965960" cy="2377440"/>
           </a:xfrm>
           <a:prstGeom prst="roundRect">
             <a:avLst>
@@ -5395,7 +5435,7 @@
         </p:blipFill>
         <p:spPr>
           <a:xfrm>
-            <a:off x="5312664" y="1828800"/>
+            <a:off x="5312664" y="1673352"/>
             <a:ext cx="347472" cy="347472"/>
           </a:xfrm>
           <a:prstGeom prst="rect">
@@ -5411,7 +5451,7 @@
         </p:nvSpPr>
         <p:spPr>
           <a:xfrm>
-            <a:off x="5312664" y="2304288"/>
+            <a:off x="5312664" y="2139696"/>
             <a:ext cx="1563624" cy="256032"/>
           </a:xfrm>
           <a:prstGeom prst="rect">
@@ -5450,7 +5490,7 @@
         </p:nvSpPr>
         <p:spPr>
           <a:xfrm>
-            <a:off x="5312664" y="2560320"/>
+            <a:off x="5312664" y="2395728"/>
             <a:ext cx="1563624" cy="292608"/>
           </a:xfrm>
           <a:prstGeom prst="rect">
@@ -5489,7 +5529,7 @@
         </p:nvSpPr>
         <p:spPr>
           <a:xfrm>
-            <a:off x="5312664" y="2852928"/>
+            <a:off x="5312664" y="2688336"/>
             <a:ext cx="1563624" cy="256032"/>
           </a:xfrm>
           <a:prstGeom prst="rect">
@@ -5528,8 +5568,8 @@
         </p:nvSpPr>
         <p:spPr>
           <a:xfrm>
-            <a:off x="5312664" y="3154680"/>
-            <a:ext cx="1600200" cy="914400"/>
+            <a:off x="5312664" y="2980944"/>
+            <a:ext cx="1600200" cy="777240"/>
           </a:xfrm>
           <a:prstGeom prst="rect">
             <a:avLst/>
@@ -5570,7 +5610,7 @@
         </p:nvSpPr>
         <p:spPr>
           <a:xfrm>
-            <a:off x="7059168" y="2606040"/>
+            <a:off x="7059168" y="2441448"/>
             <a:ext cx="352044" cy="365760"/>
           </a:xfrm>
           <a:prstGeom prst="rect">
@@ -5609,8 +5649,8 @@
         </p:nvSpPr>
         <p:spPr>
           <a:xfrm>
-            <a:off x="7392924" y="1600200"/>
-            <a:ext cx="1965960" cy="2514600"/>
+            <a:off x="7392924" y="1463040"/>
+            <a:ext cx="1965960" cy="2377440"/>
           </a:xfrm>
           <a:prstGeom prst="roundRect">
             <a:avLst>
@@ -5644,7 +5684,7 @@
         </p:blipFill>
         <p:spPr>
           <a:xfrm>
-            <a:off x="7594092" y="1828800"/>
+            <a:off x="7594092" y="1673352"/>
             <a:ext cx="347472" cy="347472"/>
           </a:xfrm>
           <a:prstGeom prst="rect">
@@ -5660,7 +5700,7 @@
         </p:nvSpPr>
         <p:spPr>
           <a:xfrm>
-            <a:off x="7594092" y="2304288"/>
+            <a:off x="7594092" y="2139696"/>
             <a:ext cx="1563624" cy="256032"/>
           </a:xfrm>
           <a:prstGeom prst="rect">
@@ -5699,7 +5739,7 @@
         </p:nvSpPr>
         <p:spPr>
           <a:xfrm>
-            <a:off x="7594092" y="2560320"/>
+            <a:off x="7594092" y="2395728"/>
             <a:ext cx="1563624" cy="292608"/>
           </a:xfrm>
           <a:prstGeom prst="rect">
@@ -5738,7 +5778,7 @@
         </p:nvSpPr>
         <p:spPr>
           <a:xfrm>
-            <a:off x="7594092" y="2852928"/>
+            <a:off x="7594092" y="2688336"/>
             <a:ext cx="1563624" cy="256032"/>
           </a:xfrm>
           <a:prstGeom prst="rect">
@@ -5777,8 +5817,8 @@
         </p:nvSpPr>
         <p:spPr>
           <a:xfrm>
-            <a:off x="7594092" y="3154680"/>
-            <a:ext cx="1600200" cy="914400"/>
+            <a:off x="7594092" y="2980944"/>
+            <a:ext cx="1600200" cy="777240"/>
           </a:xfrm>
           <a:prstGeom prst="rect">
             <a:avLst/>
@@ -5819,7 +5859,7 @@
         </p:nvSpPr>
         <p:spPr>
           <a:xfrm>
-            <a:off x="9340596" y="2606040"/>
+            <a:off x="9340596" y="2441448"/>
             <a:ext cx="352044" cy="365760"/>
           </a:xfrm>
           <a:prstGeom prst="rect">
@@ -5858,8 +5898,8 @@
         </p:nvSpPr>
         <p:spPr>
           <a:xfrm>
-            <a:off x="9674352" y="1600200"/>
-            <a:ext cx="1965960" cy="2514600"/>
+            <a:off x="9674352" y="1463040"/>
+            <a:ext cx="1965960" cy="2377440"/>
           </a:xfrm>
           <a:prstGeom prst="roundRect">
             <a:avLst>
@@ -5893,7 +5933,7 @@
         </p:blipFill>
         <p:spPr>
           <a:xfrm>
-            <a:off x="9875520" y="1828800"/>
+            <a:off x="9875520" y="1673352"/>
             <a:ext cx="347472" cy="347472"/>
           </a:xfrm>
           <a:prstGeom prst="rect">
@@ -5909,7 +5949,7 @@
         </p:nvSpPr>
         <p:spPr>
           <a:xfrm>
-            <a:off x="9875520" y="2304288"/>
+            <a:off x="9875520" y="2139696"/>
             <a:ext cx="1563624" cy="256032"/>
           </a:xfrm>
           <a:prstGeom prst="rect">
@@ -5948,7 +5988,7 @@
         </p:nvSpPr>
         <p:spPr>
           <a:xfrm>
-            <a:off x="9875520" y="2560320"/>
+            <a:off x="9875520" y="2395728"/>
             <a:ext cx="1563624" cy="292608"/>
           </a:xfrm>
           <a:prstGeom prst="rect">
@@ -5987,7 +6027,7 @@
         </p:nvSpPr>
         <p:spPr>
           <a:xfrm>
-            <a:off x="9875520" y="2852928"/>
+            <a:off x="9875520" y="2688336"/>
             <a:ext cx="1563624" cy="256032"/>
           </a:xfrm>
           <a:prstGeom prst="rect">
@@ -6026,8 +6066,8 @@
         </p:nvSpPr>
         <p:spPr>
           <a:xfrm>
-            <a:off x="9875520" y="3154680"/>
-            <a:ext cx="1600200" cy="914400"/>
+            <a:off x="9875520" y="2980944"/>
+            <a:ext cx="1600200" cy="777240"/>
           </a:xfrm>
           <a:prstGeom prst="rect">
             <a:avLst/>
@@ -6068,12 +6108,12 @@
         </p:nvSpPr>
         <p:spPr>
           <a:xfrm>
-            <a:off x="548640" y="4572000"/>
-            <a:ext cx="11091672" cy="1051560"/>
+            <a:off x="548640" y="4114800"/>
+            <a:ext cx="11091672" cy="1463040"/>
           </a:xfrm>
           <a:prstGeom prst="roundRect">
             <a:avLst>
-              <a:gd name="adj" fmla="val 6087"/>
+              <a:gd name="adj" fmla="val 4375"/>
             </a:avLst>
           </a:prstGeom>
           <a:solidFill>
@@ -6089,14 +6129,37 @@
       </p:sp>
       <p:sp>
         <p:nvSpPr>
-          <p:cNvPr id="39" name="Text 32"/>
-          <p:cNvSpPr txBox="1"/>
-          <p:nvPr/>
-        </p:nvSpPr>
-        <p:spPr>
-          <a:xfrm>
-            <a:off x="822960" y="4572000"/>
-            <a:ext cx="10515600" cy="1051560"/>
+          <p:cNvPr id="39" name="Shape 32"/>
+          <p:cNvSpPr/>
+          <p:nvPr/>
+        </p:nvSpPr>
+        <p:spPr>
+          <a:xfrm>
+            <a:off x="6263640" y="4370832"/>
+            <a:ext cx="0" cy="960120"/>
+          </a:xfrm>
+          <a:prstGeom prst="line">
+            <a:avLst/>
+          </a:prstGeom>
+          <a:noFill/>
+          <a:ln w="12700">
+            <a:solidFill>
+              <a:srgbClr val="22303F"/>
+            </a:solidFill>
+            <a:prstDash val="solid"/>
+          </a:ln>
+        </p:spPr>
+      </p:sp>
+      <p:sp>
+        <p:nvSpPr>
+          <p:cNvPr id="40" name="Text 33"/>
+          <p:cNvSpPr txBox="1"/>
+          <p:nvPr/>
+        </p:nvSpPr>
+        <p:spPr>
+          <a:xfrm>
+            <a:off x="868680" y="4315968"/>
+            <a:ext cx="5120640" cy="274320"/>
           </a:xfrm>
           <a:prstGeom prst="rect">
             <a:avLst/>
@@ -6108,69 +6171,279 @@
           <a:bodyPr wrap="square" lIns="0" tIns="0" rIns="0" bIns="0" rtlCol="0" anchor="ctr"/>
           <a:lstStyle/>
           <a:p>
-            <a:pPr algn="ctr" indent="0" marL="0">
-              <a:buNone/>
-            </a:pPr>
-            <a:r>
-              <a:rPr lang="en-US" sz="1900" b="1" dirty="0">
-                <a:solidFill>
-                  <a:srgbClr val="FF7B72"/>
+            <a:pPr indent="0" marL="0">
+              <a:buNone/>
+            </a:pPr>
+            <a:r>
+              <a:rPr lang="en-US" sz="1050" b="1" spc="150" kern="0" dirty="0">
+                <a:solidFill>
+                  <a:srgbClr val="FFB454"/>
+                </a:solidFill>
+                <a:latin typeface="Courier New" pitchFamily="34" charset="0"/>
+                <a:ea typeface="Courier New" pitchFamily="34" charset="-122"/>
+                <a:cs typeface="Courier New" pitchFamily="34" charset="-120"/>
+              </a:rPr>
+              <a:t>DAY ZERO — NEW IN v0.2.0</a:t>
+            </a:r>
+            <a:endParaRPr lang="en-US" sz="1050" dirty="0"/>
+          </a:p>
+        </p:txBody>
+      </p:sp>
+      <p:sp>
+        <p:nvSpPr>
+          <p:cNvPr id="41" name="Text 34"/>
+          <p:cNvSpPr txBox="1"/>
+          <p:nvPr/>
+        </p:nvSpPr>
+        <p:spPr>
+          <a:xfrm>
+            <a:off x="868680" y="4626864"/>
+            <a:ext cx="5120640" cy="566928"/>
+          </a:xfrm>
+          <a:prstGeom prst="rect">
+            <a:avLst/>
+          </a:prstGeom>
+          <a:noFill/>
+          <a:ln/>
+        </p:spPr>
+        <p:txBody>
+          <a:bodyPr wrap="square" lIns="0" tIns="0" rIns="0" bIns="0" rtlCol="0" anchor="t"/>
+          <a:lstStyle/>
+          <a:p>
+            <a:pPr indent="0" marL="0">
+              <a:lnSpc>
+                <a:spcPct val="115000"/>
+              </a:lnSpc>
+              <a:buNone/>
+            </a:pPr>
+            <a:r>
+              <a:rPr lang="en-US" sz="1250" dirty="0">
+                <a:solidFill>
+                  <a:srgbClr val="E9EEF5"/>
                 </a:solidFill>
                 <a:latin typeface="Arial" pitchFamily="34" charset="0"/>
                 <a:ea typeface="Arial" pitchFamily="34" charset="-122"/>
                 <a:cs typeface="Arial" pitchFamily="34" charset="-120"/>
               </a:rPr>
-              <a:t>90 minutes</a:t>
-            </a:r>
-            <a:pPr algn="ctr" indent="0" marL="0">
-              <a:buNone/>
-            </a:pPr>
-            <a:r>
-              <a:rPr lang="en-US" sz="1900" dirty="0">
-                <a:solidFill>
-                  <a:srgbClr val="E9EEF5"/>
+              <a:t>Paste a URL + a few golden examples — the Surgeon writes and proves the spec itself.</a:t>
+            </a:r>
+            <a:endParaRPr lang="en-US" sz="1250" dirty="0"/>
+          </a:p>
+        </p:txBody>
+      </p:sp>
+      <p:sp>
+        <p:nvSpPr>
+          <p:cNvPr id="42" name="Text 35"/>
+          <p:cNvSpPr txBox="1"/>
+          <p:nvPr/>
+        </p:nvSpPr>
+        <p:spPr>
+          <a:xfrm>
+            <a:off x="868680" y="5230368"/>
+            <a:ext cx="5120640" cy="256032"/>
+          </a:xfrm>
+          <a:prstGeom prst="rect">
+            <a:avLst/>
+          </a:prstGeom>
+          <a:noFill/>
+          <a:ln/>
+        </p:spPr>
+        <p:txBody>
+          <a:bodyPr wrap="square" lIns="0" tIns="0" rIns="0" bIns="0" rtlCol="0" anchor="ctr"/>
+          <a:lstStyle/>
+          <a:p>
+            <a:pPr indent="0" marL="0">
+              <a:buNone/>
+            </a:pPr>
+            <a:r>
+              <a:rPr lang="en-US" sz="1000" dirty="0">
+                <a:solidFill>
+                  <a:srgbClr val="39D3E6"/>
+                </a:solidFill>
+                <a:latin typeface="Courier New" pitchFamily="34" charset="0"/>
+                <a:ea typeface="Courier New" pitchFamily="34" charset="-122"/>
+                <a:cs typeface="Courier New" pitchFamily="34" charset="-120"/>
+              </a:rPr>
+              <a:t>books.toscrape.com · 3 examples → 20 rows @ 100%</a:t>
+            </a:r>
+            <a:endParaRPr lang="en-US" sz="1000" dirty="0"/>
+          </a:p>
+        </p:txBody>
+      </p:sp>
+      <p:sp>
+        <p:nvSpPr>
+          <p:cNvPr id="43" name="Text 36"/>
+          <p:cNvSpPr txBox="1"/>
+          <p:nvPr/>
+        </p:nvSpPr>
+        <p:spPr>
+          <a:xfrm>
+            <a:off x="6537960" y="4315968"/>
+            <a:ext cx="4754880" cy="274320"/>
+          </a:xfrm>
+          <a:prstGeom prst="rect">
+            <a:avLst/>
+          </a:prstGeom>
+          <a:noFill/>
+          <a:ln/>
+        </p:spPr>
+        <p:txBody>
+          <a:bodyPr wrap="square" lIns="0" tIns="0" rIns="0" bIns="0" rtlCol="0" anchor="ctr"/>
+          <a:lstStyle/>
+          <a:p>
+            <a:pPr indent="0" marL="0">
+              <a:buNone/>
+            </a:pPr>
+            <a:r>
+              <a:rPr lang="en-US" sz="1050" b="1" spc="150" kern="0" dirty="0">
+                <a:solidFill>
+                  <a:srgbClr val="39D3E6"/>
+                </a:solidFill>
+                <a:latin typeface="Courier New" pitchFamily="34" charset="0"/>
+                <a:ea typeface="Courier New" pitchFamily="34" charset="-122"/>
+                <a:cs typeface="Courier New" pitchFamily="34" charset="-120"/>
+              </a:rPr>
+              <a:t>EVERY BREAK AFTER</a:t>
+            </a:r>
+            <a:endParaRPr lang="en-US" sz="1050" dirty="0"/>
+          </a:p>
+        </p:txBody>
+      </p:sp>
+      <p:sp>
+        <p:nvSpPr>
+          <p:cNvPr id="44" name="Text 37"/>
+          <p:cNvSpPr txBox="1"/>
+          <p:nvPr/>
+        </p:nvSpPr>
+        <p:spPr>
+          <a:xfrm>
+            <a:off x="6537960" y="4626864"/>
+            <a:ext cx="4754880" cy="868680"/>
+          </a:xfrm>
+          <a:prstGeom prst="rect">
+            <a:avLst/>
+          </a:prstGeom>
+          <a:noFill/>
+          <a:ln/>
+        </p:spPr>
+        <p:txBody>
+          <a:bodyPr wrap="square" lIns="0" tIns="0" rIns="0" bIns="0" rtlCol="0" anchor="t"/>
+          <a:lstStyle/>
+          <a:p>
+            <a:pPr algn="l" indent="0" marL="0">
+              <a:lnSpc>
+                <a:spcPct val="115000"/>
+              </a:lnSpc>
+              <a:buNone/>
+            </a:pPr>
+            <a:r>
+              <a:rPr lang="en-US" sz="1250" b="1" dirty="0">
+                <a:solidFill>
+                  <a:srgbClr val="FF7B72"/>
                 </a:solidFill>
                 <a:latin typeface="Arial" pitchFamily="34" charset="0"/>
                 <a:ea typeface="Arial" pitchFamily="34" charset="-122"/>
                 <a:cs typeface="Arial" pitchFamily="34" charset="-120"/>
               </a:rPr>
-              <a:t> of manual selector surgery becomes a </a:t>
-            </a:r>
-            <a:pPr algn="ctr" indent="0" marL="0">
-              <a:buNone/>
-            </a:pPr>
-            <a:r>
-              <a:rPr lang="en-US" sz="1900" b="1" dirty="0">
-                <a:solidFill>
-                  <a:srgbClr val="3DDC84"/>
+              <a:t>90 minutes</a:t>
+            </a:r>
+            <a:pPr algn="l" indent="0" marL="0">
+              <a:lnSpc>
+                <a:spcPct val="115000"/>
+              </a:lnSpc>
+              <a:buNone/>
+            </a:pPr>
+            <a:r>
+              <a:rPr lang="en-US" sz="1250" dirty="0">
+                <a:solidFill>
+                  <a:srgbClr val="E9EEF5"/>
                 </a:solidFill>
                 <a:latin typeface="Arial" pitchFamily="34" charset="0"/>
                 <a:ea typeface="Arial" pitchFamily="34" charset="-122"/>
                 <a:cs typeface="Arial" pitchFamily="34" charset="-120"/>
               </a:rPr>
-              <a:t>30-second</a:t>
-            </a:r>
-            <a:pPr algn="ctr" indent="0" marL="0">
-              <a:buNone/>
-            </a:pPr>
-            <a:r>
-              <a:rPr lang="en-US" sz="1900" dirty="0">
-                <a:solidFill>
-                  <a:srgbClr val="E9EEF5"/>
+              <a:t> of manual selector surgery becomes a </a:t>
+            </a:r>
+            <a:pPr algn="l" indent="0" marL="0">
+              <a:lnSpc>
+                <a:spcPct val="115000"/>
+              </a:lnSpc>
+              <a:buNone/>
+            </a:pPr>
+            <a:r>
+              <a:rPr lang="en-US" sz="1250" b="1" dirty="0">
+                <a:solidFill>
+                  <a:srgbClr val="3DDC84"/>
                 </a:solidFill>
                 <a:latin typeface="Arial" pitchFamily="34" charset="0"/>
                 <a:ea typeface="Arial" pitchFamily="34" charset="-122"/>
                 <a:cs typeface="Arial" pitchFamily="34" charset="-120"/>
               </a:rPr>
+              <a:t>30-second</a:t>
+            </a:r>
+            <a:pPr algn="l" indent="0" marL="0">
+              <a:lnSpc>
+                <a:spcPct val="115000"/>
+              </a:lnSpc>
+              <a:buNone/>
+            </a:pPr>
+            <a:r>
+              <a:rPr lang="en-US" sz="1250" dirty="0">
+                <a:solidFill>
+                  <a:srgbClr val="E9EEF5"/>
+                </a:solidFill>
+                <a:latin typeface="Arial" pitchFamily="34" charset="0"/>
+                <a:ea typeface="Arial" pitchFamily="34" charset="-122"/>
+                <a:cs typeface="Arial" pitchFamily="34" charset="-120"/>
+              </a:rPr>
               <a:t> review-and-approve.</a:t>
             </a:r>
-            <a:endParaRPr lang="en-US" sz="1900" dirty="0"/>
-          </a:p>
-        </p:txBody>
-      </p:sp>
-      <p:sp>
-        <p:nvSpPr>
-          <p:cNvPr id="40" name="Text 33"/>
+            <a:endParaRPr lang="en-US" sz="1250" dirty="0"/>
+          </a:p>
+        </p:txBody>
+      </p:sp>
+      <p:sp>
+        <p:nvSpPr>
+          <p:cNvPr id="45" name="Text 38"/>
+          <p:cNvSpPr txBox="1"/>
+          <p:nvPr/>
+        </p:nvSpPr>
+        <p:spPr>
+          <a:xfrm>
+            <a:off x="548640" y="5806440"/>
+            <a:ext cx="11091672" cy="384048"/>
+          </a:xfrm>
+          <a:prstGeom prst="rect">
+            <a:avLst/>
+          </a:prstGeom>
+          <a:noFill/>
+          <a:ln/>
+        </p:spPr>
+        <p:txBody>
+          <a:bodyPr wrap="square" lIns="0" tIns="0" rIns="0" bIns="0" rtlCol="0" anchor="ctr"/>
+          <a:lstStyle/>
+          <a:p>
+            <a:pPr algn="ctr" indent="0" marL="0">
+              <a:buNone/>
+            </a:pPr>
+            <a:r>
+              <a:rPr lang="en-US" sz="1500" b="1" i="1" dirty="0">
+                <a:solidFill>
+                  <a:srgbClr val="FFB454"/>
+                </a:solidFill>
+                <a:latin typeface="Arial" pitchFamily="34" charset="0"/>
+                <a:ea typeface="Arial" pitchFamily="34" charset="-122"/>
+                <a:cs typeface="Arial" pitchFamily="34" charset="-120"/>
+              </a:rPr>
+              <a:t>“You never write a selector. Not even on day one.”</a:t>
+            </a:r>
+            <a:endParaRPr lang="en-US" sz="1500" dirty="0"/>
+          </a:p>
+        </p:txBody>
+      </p:sp>
+      <p:sp>
+        <p:nvSpPr>
+          <p:cNvPr id="46" name="Text 39"/>
           <p:cNvSpPr txBox="1"/>
           <p:nvPr/>
         </p:nvSpPr>
@@ -6223,7 +6496,7 @@
       </p:sp>
       <p:sp>
         <p:nvSpPr>
-          <p:cNvPr id="41" name="Text 34"/>
+          <p:cNvPr id="47" name="Text 40"/>
           <p:cNvSpPr txBox="1"/>
           <p:nvPr/>
         </p:nvSpPr>
@@ -7133,7 +7406,7 @@
                 <a:ea typeface="Arial" pitchFamily="34" charset="-122"/>
                 <a:cs typeface="Arial" pitchFamily="34" charset="-120"/>
               </a:rPr>
-              <a:t>Re-locate known-true facts — titles, prices, urls — anywhere in the redesigned DOM.</a:t>
+              <a:t>Re-locate known-true facts in node text or attributes (title= / alt=) — anywhere in the new DOM.</a:t>
             </a:r>
             <a:endParaRPr lang="en-US" sz="1200" dirty="0"/>
           </a:p>
@@ -7377,7 +7650,7 @@
                 <a:ea typeface="Arial" pitchFamily="34" charset="-122"/>
                 <a:cs typeface="Arial" pitchFamily="34" charset="-120"/>
               </a:rPr>
-              <a:t>Distill the shared CSS signature into candidate selectors for every field.</a:t>
+              <a:t>Group candidates by shape and distill shared CSS signatures — the most-specific container wins.</a:t>
             </a:r>
             <a:endParaRPr lang="en-US" sz="1200" dirty="0"/>
           </a:p>
@@ -8092,7 +8365,7 @@
                 <a:ea typeface="Courier New" pitchFamily="34" charset="-122"/>
                 <a:cs typeface="Courier New" pitchFamily="34" charset="-120"/>
               </a:rPr>
-              <a:t>• container generalized: 9 matches on page</a:t>
+              <a:t>• anchors match node text or title=/alt= attrs</a:t>
             </a:r>
             <a:endParaRPr lang="en-US" sz="1000" dirty="0"/>
           </a:p>
@@ -8112,7 +8385,7 @@
                 <a:ea typeface="Courier New" pitchFamily="34" charset="-122"/>
                 <a:cs typeface="Courier New" pitchFamily="34" charset="-120"/>
               </a:rPr>
-              <a:t>• every field validated vs 100% of anchors</a:t>
+              <a:t>• container generalized: 9 matches on page</a:t>
             </a:r>
             <a:endParaRPr lang="en-US" sz="1000" dirty="0"/>
           </a:p>
@@ -8146,20 +8419,23 @@
         </p:nvSpPr>
         <p:spPr>
           <a:xfrm>
-            <a:off x="548640" y="5806440"/>
-            <a:ext cx="11091672" cy="365760"/>
-          </a:xfrm>
-          <a:prstGeom prst="rect">
-            <a:avLst/>
-          </a:prstGeom>
-          <a:noFill/>
-          <a:ln/>
-        </p:spPr>
-        <p:txBody>
-          <a:bodyPr wrap="square" lIns="0" tIns="0" rIns="0" bIns="0" rtlCol="0" anchor="ctr"/>
-          <a:lstStyle/>
-          <a:p>
-            <a:pPr indent="0" marL="0">
+            <a:off x="548640" y="5760720"/>
+            <a:ext cx="11091672" cy="594360"/>
+          </a:xfrm>
+          <a:prstGeom prst="rect">
+            <a:avLst/>
+          </a:prstGeom>
+          <a:noFill/>
+          <a:ln/>
+        </p:spPr>
+        <p:txBody>
+          <a:bodyPr wrap="square" lIns="0" tIns="0" rIns="0" bIns="0" rtlCol="0" anchor="t"/>
+          <a:lstStyle/>
+          <a:p>
+            <a:pPr indent="0" marL="0">
+              <a:lnSpc>
+                <a:spcPct val="120000"/>
+              </a:lnSpc>
               <a:buNone/>
             </a:pPr>
             <a:r>
@@ -8174,6 +8450,9 @@
               <a:t>“Evidence over vibes”</a:t>
             </a:r>
             <a:pPr indent="0" marL="0">
+              <a:lnSpc>
+                <a:spcPct val="120000"/>
+              </a:lnSpc>
               <a:buNone/>
             </a:pPr>
             <a:r>
@@ -8185,7 +8464,7 @@
                 <a:ea typeface="Arial" pitchFamily="34" charset="-122"/>
                 <a:cs typeface="Arial" pitchFamily="34" charset="-120"/>
               </a:rPr>
-              <a:t> — every repair is proven against ground truth before a human ever sees it.</a:t>
+              <a:t> — every repair is proven against ground truth. And the same machinery onboards new sources from pasted examples — zero selectors, ever.</a:t>
             </a:r>
             <a:endParaRPr lang="en-US" sz="1400" dirty="0"/>
           </a:p>
@@ -9163,7 +9442,7 @@
                 <a:ea typeface="Arial" pitchFamily="34" charset="-122"/>
                 <a:cs typeface="Arial" pitchFamily="34" charset="-120"/>
               </a:rPr>
-              <a:t>Impact ledger</a:t>
+              <a:t>Autopilot, still gated</a:t>
             </a:r>
             <a:pPr indent="0" marL="0">
               <a:lnSpc>
@@ -9180,7 +9459,7 @@
                 <a:ea typeface="Arial" pitchFamily="34" charset="-122"/>
                 <a:cs typeface="Arial" pitchFamily="34" charset="-120"/>
               </a:rPr>
-              <a:t> books $142.50 / 90 engineer-minutes per heal — conservatively.</a:t>
+              <a:t> — continuous 60-second monitoring; every deploy still waits for a named human.</a:t>
             </a:r>
             <a:endParaRPr lang="en-US" sz="1250" dirty="0"/>
           </a:p>
@@ -9553,7 +9832,7 @@
                 <a:ea typeface="Arial" pitchFamily="34" charset="-122"/>
                 <a:cs typeface="Arial" pitchFamily="34" charset="-120"/>
               </a:rPr>
-              <a:t>Reweave ships as an MCP server that TrueForge drives end-to-end, plus a SKILL.md operator pack and approval policy.</a:t>
+              <a:t>Reweave ships as an MCP server that TrueForge drives end-to-end — onboard, run, heal, approve — plus a SKILL.md operator pack and approval policy.</a:t>
             </a:r>
             <a:endParaRPr lang="en-US" sz="1200" dirty="0"/>
           </a:p>
@@ -9595,7 +9874,7 @@
                 <a:ea typeface="Courier New" pitchFamily="34" charset="-122"/>
                 <a:cs typeface="Courier New" pitchFamily="34" charset="-120"/>
               </a:rPr>
-              <a:t>run_pipeline</a:t>
+              <a:t>9 MCP tools, incl:</a:t>
             </a:r>
             <a:endParaRPr lang="en-US" sz="1000" dirty="0"/>
           </a:p>
@@ -9615,7 +9894,27 @@
                 <a:ea typeface="Courier New" pitchFamily="34" charset="-122"/>
                 <a:cs typeface="Courier New" pitchFamily="34" charset="-120"/>
               </a:rPr>
-              <a:t>list_pending_heals</a:t>
+              <a:t>add_source · get_rows</a:t>
+            </a:r>
+            <a:endParaRPr lang="en-US" sz="1000" dirty="0"/>
+          </a:p>
+          <a:p>
+            <a:pPr indent="0" marL="0">
+              <a:lnSpc>
+                <a:spcPct val="150000"/>
+              </a:lnSpc>
+              <a:buNone/>
+            </a:pPr>
+            <a:r>
+              <a:rPr lang="en-US" sz="1000" dirty="0">
+                <a:solidFill>
+                  <a:srgbClr val="39D3E6"/>
+                </a:solidFill>
+                <a:latin typeface="Courier New" pitchFamily="34" charset="0"/>
+                <a:ea typeface="Courier New" pitchFamily="34" charset="-122"/>
+                <a:cs typeface="Courier New" pitchFamily="34" charset="-120"/>
+              </a:rPr>
+              <a:t>run_pipeline · list_pending_heals</a:t>
             </a:r>
             <a:endParaRPr lang="en-US" sz="1000" dirty="0"/>
           </a:p>
@@ -10081,7 +10380,7 @@
                 <a:ea typeface="Courier New" pitchFamily="34" charset="-122"/>
                 <a:cs typeface="Courier New" pitchFamily="34" charset="-120"/>
               </a:rPr>
-              <a:t>pytest: 13 passed</a:t>
+              <a:t>pytest: 20 passed</a:t>
             </a:r>
             <a:endParaRPr lang="en-US" sz="1000" dirty="0"/>
           </a:p>
@@ -10447,11 +10746,11 @@
         <p:spPr>
           <a:xfrm>
             <a:off x="7818120" y="1417320"/>
-            <a:ext cx="3822192" cy="1371600"/>
+            <a:ext cx="3822192" cy="1207008"/>
           </a:xfrm>
           <a:prstGeom prst="roundRect">
             <a:avLst>
-              <a:gd name="adj" fmla="val 4667"/>
+              <a:gd name="adj" fmla="val 5303"/>
             </a:avLst>
           </a:prstGeom>
           <a:solidFill>
@@ -10473,8 +10772,8 @@
         </p:nvSpPr>
         <p:spPr>
           <a:xfrm>
-            <a:off x="8092440" y="1600200"/>
-            <a:ext cx="3291840" cy="457200"/>
+            <a:off x="8092440" y="1545336"/>
+            <a:ext cx="3291840" cy="438912"/>
           </a:xfrm>
           <a:prstGeom prst="rect">
             <a:avLst/>
@@ -10512,8 +10811,8 @@
         </p:nvSpPr>
         <p:spPr>
           <a:xfrm>
-            <a:off x="8092440" y="2103120"/>
-            <a:ext cx="3291840" cy="548640"/>
+            <a:off x="8092440" y="2020824"/>
+            <a:ext cx="3291840" cy="530352"/>
           </a:xfrm>
           <a:prstGeom prst="rect">
             <a:avLst/>
@@ -10554,12 +10853,12 @@
         </p:nvSpPr>
         <p:spPr>
           <a:xfrm>
-            <a:off x="7818120" y="2935224"/>
-            <a:ext cx="3822192" cy="1371600"/>
+            <a:off x="7818120" y="2734056"/>
+            <a:ext cx="3822192" cy="1207008"/>
           </a:xfrm>
           <a:prstGeom prst="roundRect">
             <a:avLst>
-              <a:gd name="adj" fmla="val 4667"/>
+              <a:gd name="adj" fmla="val 5303"/>
             </a:avLst>
           </a:prstGeom>
           <a:solidFill>
@@ -10581,8 +10880,8 @@
         </p:nvSpPr>
         <p:spPr>
           <a:xfrm>
-            <a:off x="8092440" y="3118104"/>
-            <a:ext cx="3291840" cy="457200"/>
+            <a:off x="8092440" y="2862072"/>
+            <a:ext cx="3291840" cy="438912"/>
           </a:xfrm>
           <a:prstGeom prst="rect">
             <a:avLst/>
@@ -10620,8 +10919,8 @@
         </p:nvSpPr>
         <p:spPr>
           <a:xfrm>
-            <a:off x="8092440" y="3621024"/>
-            <a:ext cx="3291840" cy="548640"/>
+            <a:off x="8092440" y="3337560"/>
+            <a:ext cx="3291840" cy="530352"/>
           </a:xfrm>
           <a:prstGeom prst="rect">
             <a:avLst/>
@@ -10662,12 +10961,12 @@
         </p:nvSpPr>
         <p:spPr>
           <a:xfrm>
-            <a:off x="7818120" y="4453128"/>
-            <a:ext cx="3822192" cy="1371600"/>
+            <a:off x="7818120" y="4050792"/>
+            <a:ext cx="3822192" cy="1207008"/>
           </a:xfrm>
           <a:prstGeom prst="roundRect">
             <a:avLst>
-              <a:gd name="adj" fmla="val 4667"/>
+              <a:gd name="adj" fmla="val 5303"/>
             </a:avLst>
           </a:prstGeom>
           <a:solidFill>
@@ -10689,8 +10988,8 @@
         </p:nvSpPr>
         <p:spPr>
           <a:xfrm>
-            <a:off x="8092440" y="4636008"/>
-            <a:ext cx="3291840" cy="457200"/>
+            <a:off x="8092440" y="4178808"/>
+            <a:ext cx="3291840" cy="438912"/>
           </a:xfrm>
           <a:prstGeom prst="rect">
             <a:avLst/>
@@ -10728,8 +11027,8 @@
         </p:nvSpPr>
         <p:spPr>
           <a:xfrm>
-            <a:off x="8092440" y="5138928"/>
-            <a:ext cx="3291840" cy="548640"/>
+            <a:off x="8092440" y="4654296"/>
+            <a:ext cx="3291840" cy="530352"/>
           </a:xfrm>
           <a:prstGeom prst="rect">
             <a:avLst/>
@@ -10764,7 +11063,135 @@
       </p:sp>
       <p:sp>
         <p:nvSpPr>
-          <p:cNvPr id="16" name="Text 13"/>
+          <p:cNvPr id="16" name="Shape 13"/>
+          <p:cNvSpPr/>
+          <p:nvPr/>
+        </p:nvSpPr>
+        <p:spPr>
+          <a:xfrm>
+            <a:off x="7818120" y="5367528"/>
+            <a:ext cx="3822192" cy="987552"/>
+          </a:xfrm>
+          <a:prstGeom prst="roundRect">
+            <a:avLst>
+              <a:gd name="adj" fmla="val 6481"/>
+            </a:avLst>
+          </a:prstGeom>
+          <a:solidFill>
+            <a:srgbClr val="121B27"/>
+          </a:solidFill>
+          <a:ln w="12700">
+            <a:solidFill>
+              <a:srgbClr val="22303F"/>
+            </a:solidFill>
+            <a:prstDash val="solid"/>
+          </a:ln>
+        </p:spPr>
+      </p:sp>
+      <p:sp>
+        <p:nvSpPr>
+          <p:cNvPr id="17" name="Text 14"/>
+          <p:cNvSpPr txBox="1"/>
+          <p:nvPr/>
+        </p:nvSpPr>
+        <p:spPr>
+          <a:xfrm>
+            <a:off x="8092440" y="5486400"/>
+            <a:ext cx="3291840" cy="237744"/>
+          </a:xfrm>
+          <a:prstGeom prst="rect">
+            <a:avLst/>
+          </a:prstGeom>
+          <a:noFill/>
+          <a:ln/>
+        </p:spPr>
+        <p:txBody>
+          <a:bodyPr wrap="square" lIns="0" tIns="0" rIns="0" bIns="0" rtlCol="0" anchor="ctr"/>
+          <a:lstStyle/>
+          <a:p>
+            <a:pPr indent="0" marL="0">
+              <a:buNone/>
+            </a:pPr>
+            <a:r>
+              <a:rPr lang="en-US" sz="950" b="1" spc="150" kern="0" dirty="0">
+                <a:solidFill>
+                  <a:srgbClr val="8B96A8"/>
+                </a:solidFill>
+                <a:latin typeface="Courier New" pitchFamily="34" charset="0"/>
+                <a:ea typeface="Courier New" pitchFamily="34" charset="-122"/>
+                <a:cs typeface="Courier New" pitchFamily="34" charset="-120"/>
+              </a:rPr>
+              <a:t>NEW · DATA OUT + AUTOPILOT</a:t>
+            </a:r>
+            <a:endParaRPr lang="en-US" sz="950" dirty="0"/>
+          </a:p>
+        </p:txBody>
+      </p:sp>
+      <p:sp>
+        <p:nvSpPr>
+          <p:cNvPr id="18" name="Text 15"/>
+          <p:cNvSpPr txBox="1"/>
+          <p:nvPr/>
+        </p:nvSpPr>
+        <p:spPr>
+          <a:xfrm>
+            <a:off x="8092440" y="5751576"/>
+            <a:ext cx="3291840" cy="530352"/>
+          </a:xfrm>
+          <a:prstGeom prst="rect">
+            <a:avLst/>
+          </a:prstGeom>
+          <a:noFill/>
+          <a:ln/>
+        </p:spPr>
+        <p:txBody>
+          <a:bodyPr wrap="square" lIns="0" tIns="0" rIns="0" bIns="0" rtlCol="0" anchor="t"/>
+          <a:lstStyle/>
+          <a:p>
+            <a:pPr indent="0" marL="0">
+              <a:lnSpc>
+                <a:spcPct val="140000"/>
+              </a:lnSpc>
+              <a:buNone/>
+            </a:pPr>
+            <a:r>
+              <a:rPr lang="en-US" sz="950" dirty="0">
+                <a:solidFill>
+                  <a:srgbClr val="39D3E6"/>
+                </a:solidFill>
+                <a:latin typeface="Courier New" pitchFamily="34" charset="0"/>
+                <a:ea typeface="Courier New" pitchFamily="34" charset="-122"/>
+                <a:cs typeface="Courier New" pitchFamily="34" charset="-120"/>
+              </a:rPr>
+              <a:t>csv/json export · runs stored · get_rows</a:t>
+            </a:r>
+            <a:endParaRPr lang="en-US" sz="950" dirty="0"/>
+          </a:p>
+          <a:p>
+            <a:pPr indent="0" marL="0">
+              <a:lnSpc>
+                <a:spcPct val="140000"/>
+              </a:lnSpc>
+              <a:buNone/>
+            </a:pPr>
+            <a:r>
+              <a:rPr lang="en-US" sz="950" dirty="0">
+                <a:solidFill>
+                  <a:srgbClr val="3DDC84"/>
+                </a:solidFill>
+                <a:latin typeface="Courier New" pitchFamily="34" charset="0"/>
+                <a:ea typeface="Courier New" pitchFamily="34" charset="-122"/>
+                <a:cs typeface="Courier New" pitchFamily="34" charset="-120"/>
+              </a:rPr>
+              <a:t>autopilot watch · 60s · deploys human-gated</a:t>
+            </a:r>
+            <a:endParaRPr lang="en-US" sz="950" dirty="0"/>
+          </a:p>
+        </p:txBody>
+      </p:sp>
+      <p:sp>
+        <p:nvSpPr>
+          <p:cNvPr id="19" name="Text 16"/>
           <p:cNvSpPr txBox="1"/>
           <p:nvPr/>
         </p:nvSpPr>
@@ -10817,7 +11244,7 @@
       </p:sp>
       <p:sp>
         <p:nvSpPr>
-          <p:cNvPr id="17" name="Text 14"/>
+          <p:cNvPr id="20" name="Text 17"/>
           <p:cNvSpPr txBox="1"/>
           <p:nvPr/>
         </p:nvSpPr>

</xml_diff>